<commit_message>
docs(presentation): calibrate deck timeline strictly to Day 1 - Day 6 (12 - 17 Okt 2026) by Dzakwan
</commit_message>
<xml_diff>
--- a/docs/presentations/T-AIMS_Shift2_Presentation.pptx
+++ b/docs/presentations/T-AIMS_Shift2_Presentation.pptx
@@ -3278,7 +3278,7 @@
               </a:defRPr>
             </a:pPr>
             <a:r>
-              <a:t>Laporan Komprehensif Pencapaian Integrasi Shift 2 (12 s.d. 17 Oktober 2026)</a:t>
+              <a:t>Laporan Komprehensif Pencapaian Integrasi Shift 2: Hari ke-1 s.d. Hari ke-6 (12 s.d. 17 Oktober 2026)</a:t>
             </a:r>
           </a:p>
         </p:txBody>
@@ -5912,7 +5912,7 @@
               </a:defRPr>
             </a:pPr>
             <a:r>
-              <a:t>NEXT ACTION TIM SHIFT 2</a:t>
+              <a:t>NEXT ACTION TIM SHIFT 2 (HARI KE-7 DST)</a:t>
             </a:r>
           </a:p>
         </p:txBody>
@@ -5947,7 +5947,7 @@
               </a:defRPr>
             </a:pPr>
             <a:r>
-              <a:t>Roadmap Selanjutnya: Menuju Server Kantor &amp; Final Demo</a:t>
+              <a:t>Roadmap Selanjutnya: Hari ke-7 dst Menuju Server &amp; Final Demo</a:t>
             </a:r>
           </a:p>
         </p:txBody>
@@ -6788,7 +6788,7 @@
               </a:defRPr>
             </a:pPr>
             <a:r>
-              <a:t>PT TEKNOLAB CARAKA INTERNASIONAL  •  T-AIMS SHIFT 2</a:t>
+              <a:t>PT TEKNOLAB CARAKA INTERNASIONAL  •  T-AIMS SHIFT 2 (PENCAPAIAN HARI KE-1 S.D. 6)</a:t>
             </a:r>
           </a:p>
         </p:txBody>
@@ -10826,7 +10826,7 @@
               </a:defRPr>
             </a:pPr>
             <a:r>
-              <a:t>TIMELINE 13 - 15 OKTOBER 2026</a:t>
+              <a:t>TIMELINE 14 - 15 OKTOBER 2026</a:t>
             </a:r>
           </a:p>
         </p:txBody>
@@ -11387,7 +11387,7 @@
               </a:defRPr>
             </a:pPr>
             <a:r>
-              <a:t>TIMELINE 15 - 17 OKTOBER 2026</a:t>
+              <a:t>TIMELINE 16 - 17 OKTOBER 2026</a:t>
             </a:r>
           </a:p>
         </p:txBody>
@@ -11422,7 +11422,7 @@
               </a:defRPr>
             </a:pPr>
             <a:r>
-              <a:t>Kronologi Proyek: Hari 5, 6 &amp; 7 (Zero Defect &amp; Rilis)</a:t>
+              <a:t>Kronologi Proyek: Hari 5 &amp; 6 (Zero Defect &amp; Rilis)</a:t>
             </a:r>
           </a:p>
         </p:txBody>
@@ -11502,7 +11502,7 @@
               </a:defRPr>
             </a:pPr>
             <a:r>
-              <a:t>Hari ke-5 (16 Okt 2026)</a:t>
+              <a:t>Hari ke-5 (Jumat, 16 Okt 2026)</a:t>
             </a:r>
           </a:p>
           <a:p>
@@ -11514,7 +11514,7 @@
               </a:defRPr>
             </a:pPr>
             <a:r>
-              <a:t>Daemon Systemd &amp; Audit Sisi Server</a:t>
+              <a:t>Daemon Systemd &amp; Audit Server</a:t>
             </a:r>
           </a:p>
         </p:txBody>
@@ -11677,7 +11677,7 @@
               </a:defRPr>
             </a:pPr>
             <a:r>
-              <a:t>Hari ke-6 (16-17 Okt 2026)</a:t>
+              <a:t>Hari ke-6 Sesi Dini Hari (17 Okt)</a:t>
             </a:r>
           </a:p>
           <a:p>
@@ -11852,7 +11852,7 @@
               </a:defRPr>
             </a:pPr>
             <a:r>
-              <a:t>Hari ke-7 (17 Okt 2026)</a:t>
+              <a:t>Hari ke-6 Sesi Siang/Sore (17 Okt)</a:t>
             </a:r>
           </a:p>
           <a:p>

</xml_diff>